<commit_message>
chore: updated ddm behav and param plots
</commit_message>
<xml_diff>
--- a/dissemination/ddm/ddm_group_comparison.pptx
+++ b/dissemination/ddm/ddm_group_comparison.pptx
@@ -3252,7 +3252,7 @@
         <p:spPr>
           <a:xfrm>
             <a:off x="914400" y="1371600"/>
-            <a:ext cx="7315200" cy="3223094"/>
+            <a:ext cx="7315200" cy="3150487"/>
           </a:xfrm>
           <a:prstGeom prst="rect">
             <a:avLst/>
@@ -3315,7 +3315,7 @@
         <p:spPr>
           <a:xfrm>
             <a:off x="914400" y="1371600"/>
-            <a:ext cx="7315200" cy="1283540"/>
+            <a:ext cx="7315200" cy="2315011"/>
           </a:xfrm>
           <a:prstGeom prst="rect">
             <a:avLst/>
@@ -3434,7 +3434,7 @@
         <p:spPr>
           <a:xfrm>
             <a:off x="914400" y="1371600"/>
-            <a:ext cx="7315200" cy="3223094"/>
+            <a:ext cx="7315200" cy="3150487"/>
           </a:xfrm>
           <a:prstGeom prst="rect">
             <a:avLst/>
@@ -3497,7 +3497,7 @@
         <p:spPr>
           <a:xfrm>
             <a:off x="914400" y="1371600"/>
-            <a:ext cx="7315200" cy="1283540"/>
+            <a:ext cx="7315200" cy="2315011"/>
           </a:xfrm>
           <a:prstGeom prst="rect">
             <a:avLst/>
@@ -3560,7 +3560,7 @@
         <p:spPr>
           <a:xfrm>
             <a:off x="914400" y="1371600"/>
-            <a:ext cx="7315200" cy="3223094"/>
+            <a:ext cx="7315200" cy="3150487"/>
           </a:xfrm>
           <a:prstGeom prst="rect">
             <a:avLst/>
@@ -3623,7 +3623,7 @@
         <p:spPr>
           <a:xfrm>
             <a:off x="914400" y="1371600"/>
-            <a:ext cx="7315200" cy="1283540"/>
+            <a:ext cx="7315200" cy="2315011"/>
           </a:xfrm>
           <a:prstGeom prst="rect">
             <a:avLst/>
@@ -3742,7 +3742,7 @@
         <p:spPr>
           <a:xfrm>
             <a:off x="914400" y="1371600"/>
-            <a:ext cx="7315200" cy="3223094"/>
+            <a:ext cx="7315200" cy="3150487"/>
           </a:xfrm>
           <a:prstGeom prst="rect">
             <a:avLst/>
@@ -3805,7 +3805,7 @@
         <p:spPr>
           <a:xfrm>
             <a:off x="914400" y="1371600"/>
-            <a:ext cx="7315200" cy="1283826"/>
+            <a:ext cx="7315200" cy="2315011"/>
           </a:xfrm>
           <a:prstGeom prst="rect">
             <a:avLst/>
@@ -3924,7 +3924,7 @@
         <p:spPr>
           <a:xfrm>
             <a:off x="914400" y="1371600"/>
-            <a:ext cx="7315200" cy="3223094"/>
+            <a:ext cx="7315200" cy="3150487"/>
           </a:xfrm>
           <a:prstGeom prst="rect">
             <a:avLst/>
@@ -3987,7 +3987,7 @@
         <p:spPr>
           <a:xfrm>
             <a:off x="914400" y="1371600"/>
-            <a:ext cx="7315200" cy="1283540"/>
+            <a:ext cx="7315200" cy="2315011"/>
           </a:xfrm>
           <a:prstGeom prst="rect">
             <a:avLst/>

</xml_diff>